<commit_message>
Update deck colors to Midnight Executive palette
</commit_message>
<xml_diff>
--- a/Tracey-Scott-Portfolio.pptx
+++ b/Tracey-Scott-Portfolio.pptx
@@ -128,7 +128,7 @@
             <a:pPr>
               <a:defRPr sz="1400" b="0" i="0" u="none" strike="noStrike">
                 <a:solidFill>
-                  <a:srgbClr val="2C5F2D"/>
+                  <a:srgbClr val="1E2761"/>
                 </a:solidFill>
                 <a:latin typeface="Arial"/>
               </a:defRPr>
@@ -136,7 +136,7 @@
             <a:r>
               <a:rPr sz="1400" b="0" i="0" u="none" strike="noStrike">
                 <a:solidFill>
-                  <a:srgbClr val="2C5F2D"/>
+                  <a:srgbClr val="1E2761"/>
                 </a:solidFill>
                 <a:latin typeface="Arial"/>
               </a:rPr>
@@ -169,11 +169,11 @@
           </c:tx>
           <c:spPr>
             <a:solidFill>
-              <a:srgbClr val="D4A017"/>
+              <a:srgbClr val="F59E0B"/>
             </a:solidFill>
             <a:ln w="38100" cap="flat">
               <a:solidFill>
-                <a:srgbClr val="D4A017"/>
+                <a:srgbClr val="F59E0B"/>
               </a:solidFill>
               <a:prstDash val="solid"/>
               <a:round/>
@@ -190,7 +190,7 @@
                 <a:pPr>
                   <a:defRPr b="0" i="0" strike="noStrike" sz="1200" u="none">
                     <a:solidFill>
-                      <a:srgbClr val="1A2E1A"/>
+                      <a:srgbClr val="0F172A"/>
                     </a:solidFill>
                     <a:latin typeface="Arial"/>
                   </a:defRPr>
@@ -210,11 +210,11 @@
             <c:size val="6"/>
             <c:spPr>
               <a:solidFill>
-                <a:srgbClr val="D4A017"/>
+                <a:srgbClr val="F59E0B"/>
               </a:solidFill>
               <a:ln w="9525" cap="flat">
                 <a:solidFill>
-                  <a:srgbClr val="D4A017"/>
+                  <a:srgbClr val="F59E0B"/>
                 </a:solidFill>
                 <a:prstDash val="solid"/>
                 <a:round/>
@@ -288,7 +288,7 @@
               <a:pPr>
                 <a:defRPr b="0" i="0" strike="noStrike" sz="1200" u="none">
                   <a:solidFill>
-                    <a:srgbClr val="1A2E1A"/>
+                    <a:srgbClr val="0F172A"/>
                   </a:solidFill>
                   <a:latin typeface="Arial"/>
                 </a:defRPr>
@@ -335,7 +335,7 @@
             <a:pPr>
               <a:defRPr sz="1200" b="0" i="0" u="none" strike="noStrike">
                 <a:solidFill>
-                  <a:srgbClr val="6B7C5C"/>
+                  <a:srgbClr val="64748B"/>
                 </a:solidFill>
                 <a:latin typeface="Arial"/>
               </a:defRPr>
@@ -387,7 +387,7 @@
             <a:pPr>
               <a:defRPr sz="1200" b="0" i="0" u="none" strike="noStrike">
                 <a:solidFill>
-                  <a:srgbClr val="6B7C5C"/>
+                  <a:srgbClr val="64748B"/>
                 </a:solidFill>
                 <a:latin typeface="Arial"/>
               </a:defRPr>
@@ -439,7 +439,7 @@
             <a:pPr>
               <a:defRPr sz="1400" b="0" i="0" u="none" strike="noStrike">
                 <a:solidFill>
-                  <a:srgbClr val="2C5F2D"/>
+                  <a:srgbClr val="1E2761"/>
                 </a:solidFill>
                 <a:latin typeface="Arial"/>
               </a:defRPr>
@@ -447,7 +447,7 @@
             <a:r>
               <a:rPr sz="1400" b="0" i="0" u="none" strike="noStrike">
                 <a:solidFill>
-                  <a:srgbClr val="2C5F2D"/>
+                  <a:srgbClr val="1E2761"/>
                 </a:solidFill>
                 <a:latin typeface="Arial"/>
               </a:rPr>
@@ -496,7 +496,7 @@
             <c:bubble3D val="0"/>
             <c:spPr>
               <a:solidFill>
-                <a:srgbClr val="2C5F2D"/>
+                <a:srgbClr val="1E2761"/>
               </a:solidFill>
               <a:effectLst/>
             </c:spPr>
@@ -506,7 +506,7 @@
             <c:bubble3D val="0"/>
             <c:spPr>
               <a:solidFill>
-                <a:srgbClr val="97BC62"/>
+                <a:srgbClr val="CADCFC"/>
               </a:solidFill>
               <a:effectLst/>
             </c:spPr>
@@ -523,7 +523,7 @@
                   <a:pPr>
                     <a:defRPr sz="1200" b="0" i="0" u="none" strike="noStrike">
                       <a:solidFill>
-                        <a:srgbClr val="F5F5F5"/>
+                        <a:srgbClr val="FFFFFF"/>
                       </a:solidFill>
                       <a:latin typeface="Arial"/>
                     </a:defRPr>
@@ -548,7 +548,7 @@
                   <a:pPr>
                     <a:defRPr sz="1200" b="0" i="0" u="none" strike="noStrike">
                       <a:solidFill>
-                        <a:srgbClr val="F5F5F5"/>
+                        <a:srgbClr val="FFFFFF"/>
                       </a:solidFill>
                       <a:latin typeface="Arial"/>
                     </a:defRPr>
@@ -669,7 +669,7 @@
           </c:tx>
           <c:spPr>
             <a:solidFill>
-              <a:srgbClr val="2C5F2D"/>
+              <a:srgbClr val="1E2761"/>
             </a:solidFill>
             <a:effectLst/>
           </c:spPr>
@@ -683,7 +683,7 @@
                 <a:pPr>
                   <a:defRPr b="0" i="0" strike="noStrike" sz="1200" u="none">
                     <a:solidFill>
-                      <a:srgbClr val="1A2E1A"/>
+                      <a:srgbClr val="0F172A"/>
                     </a:solidFill>
                     <a:latin typeface="Arial"/>
                   </a:defRPr>
@@ -775,7 +775,7 @@
               <a:pPr>
                 <a:defRPr b="0" i="0" strike="noStrike" sz="1200" u="none">
                   <a:solidFill>
-                    <a:srgbClr val="1A2E1A"/>
+                    <a:srgbClr val="0F172A"/>
                   </a:solidFill>
                   <a:latin typeface="Arial"/>
                 </a:defRPr>
@@ -823,7 +823,7 @@
             <a:pPr>
               <a:defRPr sz="1300" b="0" i="0" u="none" strike="noStrike">
                 <a:solidFill>
-                  <a:srgbClr val="1A2E1A"/>
+                  <a:srgbClr val="0F172A"/>
                 </a:solidFill>
                 <a:latin typeface="Arial"/>
               </a:defRPr>
@@ -877,7 +877,7 @@
             <a:pPr>
               <a:defRPr sz="1200" b="0" i="0" u="none" strike="noStrike">
                 <a:solidFill>
-                  <a:srgbClr val="6B7C5C"/>
+                  <a:srgbClr val="64748B"/>
                 </a:solidFill>
                 <a:latin typeface="Arial"/>
               </a:defRPr>
@@ -2281,7 +2281,7 @@
     <p:bg>
       <p:bgPr>
         <a:solidFill>
-          <a:srgbClr val="2C5F2D"/>
+          <a:srgbClr val="1E2761"/>
         </a:solidFill>
       </p:bgPr>
     </p:bg>
@@ -2314,7 +2314,7 @@
             <a:avLst/>
           </a:prstGeom>
           <a:solidFill>
-            <a:srgbClr val="D4A017"/>
+            <a:srgbClr val="F59E0B"/>
           </a:solidFill>
           <a:ln/>
         </p:spPr>
@@ -2346,7 +2346,7 @@
             <a:r>
               <a:rPr lang="en-US" sz="6000" b="1" spc="200" kern="0" dirty="0">
                 <a:solidFill>
-                  <a:srgbClr val="F5F5F5"/>
+                  <a:srgbClr val="FFFFFF"/>
                 </a:solidFill>
                 <a:latin typeface="Georgia" pitchFamily="34" charset="0"/>
                 <a:ea typeface="Georgia" pitchFamily="34" charset="-122"/>
@@ -2385,7 +2385,7 @@
             <a:r>
               <a:rPr lang="en-US" sz="2200" dirty="0">
                 <a:solidFill>
-                  <a:srgbClr val="97BC62"/>
+                  <a:srgbClr val="CADCFC"/>
                 </a:solidFill>
                 <a:latin typeface="Calibri" pitchFamily="34" charset="0"/>
                 <a:ea typeface="Calibri" pitchFamily="34" charset="-122"/>
@@ -2412,7 +2412,7 @@
             <a:avLst/>
           </a:prstGeom>
           <a:solidFill>
-            <a:srgbClr val="D4A017"/>
+            <a:srgbClr val="F59E0B"/>
           </a:solidFill>
           <a:ln/>
         </p:spPr>
@@ -2444,7 +2444,7 @@
             <a:r>
               <a:rPr lang="en-US" sz="1600" dirty="0">
                 <a:solidFill>
-                  <a:srgbClr val="F5F5F5"/>
+                  <a:srgbClr val="FFFFFF"/>
                 </a:solidFill>
               </a:rPr>
               <a:t>IT Operations Manager &amp; Business Analyst  |  Greenville, SC</a:t>
@@ -2480,7 +2480,7 @@
             <a:r>
               <a:rPr lang="en-US" sz="1400" i="1" dirty="0">
                 <a:solidFill>
-                  <a:srgbClr val="D4A017"/>
+                  <a:srgbClr val="F59E0B"/>
                 </a:solidFill>
               </a:rPr>
               <a:t>Portfolio Deck  •  2026</a:t>
@@ -2503,7 +2503,7 @@
     <p:bg>
       <p:bgPr>
         <a:solidFill>
-          <a:srgbClr val="F5F5F5"/>
+          <a:srgbClr val="FFFFFF"/>
         </a:solidFill>
       </p:bgPr>
     </p:bg>
@@ -2548,7 +2548,7 @@
             <a:r>
               <a:rPr lang="en-US" sz="4000" b="1" dirty="0">
                 <a:solidFill>
-                  <a:srgbClr val="2C5F2D"/>
+                  <a:srgbClr val="1E2761"/>
                 </a:solidFill>
                 <a:latin typeface="Georgia" pitchFamily="34" charset="0"/>
                 <a:ea typeface="Georgia" pitchFamily="34" charset="-122"/>
@@ -2575,7 +2575,7 @@
             <a:avLst/>
           </a:prstGeom>
           <a:solidFill>
-            <a:srgbClr val="97BC62"/>
+            <a:srgbClr val="CADCFC"/>
           </a:solidFill>
           <a:ln/>
         </p:spPr>
@@ -2610,7 +2610,7 @@
             <a:r>
               <a:rPr lang="en-US" sz="1500" dirty="0">
                 <a:solidFill>
-                  <a:srgbClr val="1A2E1A"/>
+                  <a:srgbClr val="0F172A"/>
                 </a:solidFill>
                 <a:latin typeface="Calibri" pitchFamily="34" charset="0"/>
                 <a:ea typeface="Calibri" pitchFamily="34" charset="-122"/>
@@ -2630,7 +2630,7 @@
             <a:r>
               <a:rPr lang="en-US" sz="1500" dirty="0">
                 <a:solidFill>
-                  <a:srgbClr val="1A2E1A"/>
+                  <a:srgbClr val="0F172A"/>
                 </a:solidFill>
                 <a:latin typeface="Calibri" pitchFamily="34" charset="0"/>
                 <a:ea typeface="Calibri" pitchFamily="34" charset="-122"/>
@@ -2647,7 +2647,7 @@
             <a:r>
               <a:rPr lang="en-US" sz="1500" dirty="0">
                 <a:solidFill>
-                  <a:srgbClr val="1A2E1A"/>
+                  <a:srgbClr val="0F172A"/>
                 </a:solidFill>
                 <a:latin typeface="Calibri" pitchFamily="34" charset="0"/>
                 <a:ea typeface="Calibri" pitchFamily="34" charset="-122"/>
@@ -2674,7 +2674,7 @@
             <a:avLst/>
           </a:prstGeom>
           <a:solidFill>
-            <a:srgbClr val="2C5F2D"/>
+            <a:srgbClr val="1E2761"/>
           </a:solidFill>
           <a:ln/>
         </p:spPr>
@@ -2694,7 +2694,7 @@
             <a:avLst/>
           </a:prstGeom>
           <a:solidFill>
-            <a:srgbClr val="D4A017"/>
+            <a:srgbClr val="F59E0B"/>
           </a:solidFill>
           <a:ln/>
         </p:spPr>
@@ -2726,7 +2726,7 @@
             <a:r>
               <a:rPr lang="en-US" sz="4800" b="1" dirty="0">
                 <a:solidFill>
-                  <a:srgbClr val="F5F5F5"/>
+                  <a:srgbClr val="FFFFFF"/>
                 </a:solidFill>
                 <a:latin typeface="Georgia" pitchFamily="34" charset="0"/>
                 <a:ea typeface="Georgia" pitchFamily="34" charset="-122"/>
@@ -2765,7 +2765,7 @@
             <a:r>
               <a:rPr lang="en-US" sz="1300" dirty="0">
                 <a:solidFill>
-                  <a:srgbClr val="97BC62"/>
+                  <a:srgbClr val="CADCFC"/>
                 </a:solidFill>
               </a:rPr>
               <a:t>Years Experience</a:t>
@@ -2789,7 +2789,7 @@
             <a:avLst/>
           </a:prstGeom>
           <a:solidFill>
-            <a:srgbClr val="2C5F2D"/>
+            <a:srgbClr val="1E2761"/>
           </a:solidFill>
           <a:ln/>
         </p:spPr>
@@ -2809,7 +2809,7 @@
             <a:avLst/>
           </a:prstGeom>
           <a:solidFill>
-            <a:srgbClr val="D4A017"/>
+            <a:srgbClr val="F59E0B"/>
           </a:solidFill>
           <a:ln/>
         </p:spPr>
@@ -2841,7 +2841,7 @@
             <a:r>
               <a:rPr lang="en-US" sz="4800" b="1" dirty="0">
                 <a:solidFill>
-                  <a:srgbClr val="F5F5F5"/>
+                  <a:srgbClr val="FFFFFF"/>
                 </a:solidFill>
                 <a:latin typeface="Georgia" pitchFamily="34" charset="0"/>
                 <a:ea typeface="Georgia" pitchFamily="34" charset="-122"/>
@@ -2880,7 +2880,7 @@
             <a:r>
               <a:rPr lang="en-US" sz="1300" dirty="0">
                 <a:solidFill>
-                  <a:srgbClr val="97BC62"/>
+                  <a:srgbClr val="CADCFC"/>
                 </a:solidFill>
               </a:rPr>
               <a:t>Months to Full Security Framework</a:t>
@@ -2904,7 +2904,7 @@
             <a:avLst/>
           </a:prstGeom>
           <a:solidFill>
-            <a:srgbClr val="2C5F2D"/>
+            <a:srgbClr val="1E2761"/>
           </a:solidFill>
           <a:ln/>
         </p:spPr>
@@ -2924,7 +2924,7 @@
             <a:avLst/>
           </a:prstGeom>
           <a:solidFill>
-            <a:srgbClr val="D4A017"/>
+            <a:srgbClr val="F59E0B"/>
           </a:solidFill>
           <a:ln/>
         </p:spPr>
@@ -2956,7 +2956,7 @@
             <a:r>
               <a:rPr lang="en-US" sz="4800" b="1" dirty="0">
                 <a:solidFill>
-                  <a:srgbClr val="F5F5F5"/>
+                  <a:srgbClr val="FFFFFF"/>
                 </a:solidFill>
                 <a:latin typeface="Georgia" pitchFamily="34" charset="0"/>
                 <a:ea typeface="Georgia" pitchFamily="34" charset="-122"/>
@@ -2995,7 +2995,7 @@
             <a:r>
               <a:rPr lang="en-US" sz="1300" dirty="0">
                 <a:solidFill>
-                  <a:srgbClr val="97BC62"/>
+                  <a:srgbClr val="CADCFC"/>
                 </a:solidFill>
               </a:rPr>
               <a:t>Predictive Model Accuracy</a:t>
@@ -3019,7 +3019,7 @@
             <a:avLst/>
           </a:prstGeom>
           <a:solidFill>
-            <a:srgbClr val="2C5F2D"/>
+            <a:srgbClr val="1E2761"/>
           </a:solidFill>
           <a:ln/>
         </p:spPr>
@@ -3039,7 +3039,7 @@
             <a:avLst/>
           </a:prstGeom>
           <a:solidFill>
-            <a:srgbClr val="D4A017"/>
+            <a:srgbClr val="F59E0B"/>
           </a:solidFill>
           <a:ln/>
         </p:spPr>
@@ -3071,7 +3071,7 @@
             <a:r>
               <a:rPr lang="en-US" sz="4800" b="1" dirty="0">
                 <a:solidFill>
-                  <a:srgbClr val="F5F5F5"/>
+                  <a:srgbClr val="FFFFFF"/>
                 </a:solidFill>
                 <a:latin typeface="Georgia" pitchFamily="34" charset="0"/>
                 <a:ea typeface="Georgia" pitchFamily="34" charset="-122"/>
@@ -3110,7 +3110,7 @@
             <a:r>
               <a:rPr lang="en-US" sz="1300" dirty="0">
                 <a:solidFill>
-                  <a:srgbClr val="97BC62"/>
+                  <a:srgbClr val="CADCFC"/>
                 </a:solidFill>
               </a:rPr>
               <a:t>Clouds (AWS • Azure • GCP)</a:t>
@@ -3134,7 +3134,7 @@
             <a:avLst/>
           </a:prstGeom>
           <a:solidFill>
-            <a:srgbClr val="2C5F2D"/>
+            <a:srgbClr val="1E2761"/>
           </a:solidFill>
           <a:ln/>
         </p:spPr>
@@ -3166,7 +3166,7 @@
             <a:r>
               <a:rPr lang="en-US" sz="1000" dirty="0">
                 <a:solidFill>
-                  <a:srgbClr val="97BC62"/>
+                  <a:srgbClr val="CADCFC"/>
                 </a:solidFill>
               </a:rPr>
               <a:t>Tracey Scott  |  Cybersecurity • Cloud • SOC  |  traceysscott82@gmail.com</a:t>
@@ -3202,7 +3202,7 @@
             <a:r>
               <a:rPr lang="en-US" sz="1000" dirty="0">
                 <a:solidFill>
-                  <a:srgbClr val="97BC62"/>
+                  <a:srgbClr val="CADCFC"/>
                 </a:solidFill>
               </a:rPr>
               <a:t>2</a:t>
@@ -3225,7 +3225,7 @@
     <p:bg>
       <p:bgPr>
         <a:solidFill>
-          <a:srgbClr val="F5F5F5"/>
+          <a:srgbClr val="FFFFFF"/>
         </a:solidFill>
       </p:bgPr>
     </p:bg>
@@ -3270,7 +3270,7 @@
             <a:r>
               <a:rPr lang="en-US" sz="3600" b="1" dirty="0">
                 <a:solidFill>
-                  <a:srgbClr val="2C5F2D"/>
+                  <a:srgbClr val="1E2761"/>
                 </a:solidFill>
                 <a:latin typeface="Georgia" pitchFamily="34" charset="0"/>
                 <a:ea typeface="Georgia" pitchFamily="34" charset="-122"/>
@@ -3297,11 +3297,11 @@
             <a:avLst/>
           </a:prstGeom>
           <a:solidFill>
-            <a:srgbClr val="F5F5F5"/>
+            <a:srgbClr val="FFFFFF"/>
           </a:solidFill>
           <a:ln w="12700">
             <a:solidFill>
-              <a:srgbClr val="97BC62"/>
+              <a:srgbClr val="CADCFC"/>
             </a:solidFill>
             <a:prstDash val="solid"/>
           </a:ln>
@@ -3329,7 +3329,7 @@
             <a:avLst/>
           </a:prstGeom>
           <a:solidFill>
-            <a:srgbClr val="D4A017"/>
+            <a:srgbClr val="F59E0B"/>
           </a:solidFill>
           <a:ln/>
         </p:spPr>
@@ -3361,7 +3361,7 @@
             <a:r>
               <a:rPr lang="en-US" sz="1800" b="1" dirty="0">
                 <a:solidFill>
-                  <a:srgbClr val="2C5F2D"/>
+                  <a:srgbClr val="1E2761"/>
                 </a:solidFill>
                 <a:latin typeface="Georgia" pitchFamily="34" charset="0"/>
                 <a:ea typeface="Georgia" pitchFamily="34" charset="-122"/>
@@ -3401,7 +3401,7 @@
             <a:r>
               <a:rPr lang="en-US" sz="1300" dirty="0">
                 <a:solidFill>
-                  <a:srgbClr val="1A2E1A"/>
+                  <a:srgbClr val="0F172A"/>
                 </a:solidFill>
               </a:rPr>
               <a:t>IDS/IPS &amp; Firewall Admin</a:t>
@@ -3416,7 +3416,7 @@
             <a:r>
               <a:rPr lang="en-US" sz="1300" dirty="0">
                 <a:solidFill>
-                  <a:srgbClr val="1A2E1A"/>
+                  <a:srgbClr val="0F172A"/>
                 </a:solidFill>
               </a:rPr>
               <a:t>Endpoint / EDR &amp; MDM</a:t>
@@ -3431,7 +3431,7 @@
             <a:r>
               <a:rPr lang="en-US" sz="1300" dirty="0">
                 <a:solidFill>
-                  <a:srgbClr val="1A2E1A"/>
+                  <a:srgbClr val="0F172A"/>
                 </a:solidFill>
               </a:rPr>
               <a:t>Incident Response</a:t>
@@ -3446,7 +3446,7 @@
             <a:r>
               <a:rPr lang="en-US" sz="1300" dirty="0">
                 <a:solidFill>
-                  <a:srgbClr val="1A2E1A"/>
+                  <a:srgbClr val="0F172A"/>
                 </a:solidFill>
               </a:rPr>
               <a:t>Log Analysis &amp; SIEM</a:t>
@@ -3470,11 +3470,11 @@
             <a:avLst/>
           </a:prstGeom>
           <a:solidFill>
-            <a:srgbClr val="F5F5F5"/>
+            <a:srgbClr val="FFFFFF"/>
           </a:solidFill>
           <a:ln w="12700">
             <a:solidFill>
-              <a:srgbClr val="97BC62"/>
+              <a:srgbClr val="CADCFC"/>
             </a:solidFill>
             <a:prstDash val="solid"/>
           </a:ln>
@@ -3502,7 +3502,7 @@
             <a:avLst/>
           </a:prstGeom>
           <a:solidFill>
-            <a:srgbClr val="D4A017"/>
+            <a:srgbClr val="F59E0B"/>
           </a:solidFill>
           <a:ln/>
         </p:spPr>
@@ -3534,7 +3534,7 @@
             <a:r>
               <a:rPr lang="en-US" sz="1800" b="1" dirty="0">
                 <a:solidFill>
-                  <a:srgbClr val="2C5F2D"/>
+                  <a:srgbClr val="1E2761"/>
                 </a:solidFill>
                 <a:latin typeface="Georgia" pitchFamily="34" charset="0"/>
                 <a:ea typeface="Georgia" pitchFamily="34" charset="-122"/>
@@ -3574,7 +3574,7 @@
             <a:r>
               <a:rPr lang="en-US" sz="1300" dirty="0">
                 <a:solidFill>
-                  <a:srgbClr val="1A2E1A"/>
+                  <a:srgbClr val="0F172A"/>
                 </a:solidFill>
               </a:rPr>
               <a:t>AWS, Azure, GCP</a:t>
@@ -3589,7 +3589,7 @@
             <a:r>
               <a:rPr lang="en-US" sz="1300" dirty="0">
                 <a:solidFill>
-                  <a:srgbClr val="1A2E1A"/>
+                  <a:srgbClr val="0F172A"/>
                 </a:solidFill>
               </a:rPr>
               <a:t>IAM / RBAC / Azure AD</a:t>
@@ -3604,7 +3604,7 @@
             <a:r>
               <a:rPr lang="en-US" sz="1300" dirty="0">
                 <a:solidFill>
-                  <a:srgbClr val="1A2E1A"/>
+                  <a:srgbClr val="0F172A"/>
                 </a:solidFill>
               </a:rPr>
               <a:t>VMware, Hyper-V, Docker</a:t>
@@ -3619,7 +3619,7 @@
             <a:r>
               <a:rPr lang="en-US" sz="1300" dirty="0">
                 <a:solidFill>
-                  <a:srgbClr val="1A2E1A"/>
+                  <a:srgbClr val="0F172A"/>
                 </a:solidFill>
               </a:rPr>
               <a:t>M365 &amp; SaaS Admin</a:t>
@@ -3643,11 +3643,11 @@
             <a:avLst/>
           </a:prstGeom>
           <a:solidFill>
-            <a:srgbClr val="F5F5F5"/>
+            <a:srgbClr val="FFFFFF"/>
           </a:solidFill>
           <a:ln w="12700">
             <a:solidFill>
-              <a:srgbClr val="97BC62"/>
+              <a:srgbClr val="CADCFC"/>
             </a:solidFill>
             <a:prstDash val="solid"/>
           </a:ln>
@@ -3675,7 +3675,7 @@
             <a:avLst/>
           </a:prstGeom>
           <a:solidFill>
-            <a:srgbClr val="D4A017"/>
+            <a:srgbClr val="F59E0B"/>
           </a:solidFill>
           <a:ln/>
         </p:spPr>
@@ -3707,7 +3707,7 @@
             <a:r>
               <a:rPr lang="en-US" sz="1800" b="1" dirty="0">
                 <a:solidFill>
-                  <a:srgbClr val="2C5F2D"/>
+                  <a:srgbClr val="1E2761"/>
                 </a:solidFill>
                 <a:latin typeface="Georgia" pitchFamily="34" charset="0"/>
                 <a:ea typeface="Georgia" pitchFamily="34" charset="-122"/>
@@ -3747,7 +3747,7 @@
             <a:r>
               <a:rPr lang="en-US" sz="1300" dirty="0">
                 <a:solidFill>
-                  <a:srgbClr val="1A2E1A"/>
+                  <a:srgbClr val="0F172A"/>
                 </a:solidFill>
               </a:rPr>
               <a:t>GDPR, SOX, ITIL</a:t>
@@ -3762,7 +3762,7 @@
             <a:r>
               <a:rPr lang="en-US" sz="1300" dirty="0">
                 <a:solidFill>
-                  <a:srgbClr val="1A2E1A"/>
+                  <a:srgbClr val="0F172A"/>
                 </a:solidFill>
               </a:rPr>
               <a:t>Risk Assessment</a:t>
@@ -3777,7 +3777,7 @@
             <a:r>
               <a:rPr lang="en-US" sz="1300" dirty="0">
                 <a:solidFill>
-                  <a:srgbClr val="1A2E1A"/>
+                  <a:srgbClr val="0F172A"/>
                 </a:solidFill>
               </a:rPr>
               <a:t>Vulnerability Management</a:t>
@@ -3792,7 +3792,7 @@
             <a:r>
               <a:rPr lang="en-US" sz="1300" dirty="0">
                 <a:solidFill>
-                  <a:srgbClr val="1A2E1A"/>
+                  <a:srgbClr val="0F172A"/>
                 </a:solidFill>
               </a:rPr>
               <a:t>Security Policy Design</a:t>
@@ -3816,11 +3816,11 @@
             <a:avLst/>
           </a:prstGeom>
           <a:solidFill>
-            <a:srgbClr val="F5F5F5"/>
+            <a:srgbClr val="FFFFFF"/>
           </a:solidFill>
           <a:ln w="12700">
             <a:solidFill>
-              <a:srgbClr val="97BC62"/>
+              <a:srgbClr val="CADCFC"/>
             </a:solidFill>
             <a:prstDash val="solid"/>
           </a:ln>
@@ -3848,7 +3848,7 @@
             <a:avLst/>
           </a:prstGeom>
           <a:solidFill>
-            <a:srgbClr val="D4A017"/>
+            <a:srgbClr val="F59E0B"/>
           </a:solidFill>
           <a:ln/>
         </p:spPr>
@@ -3880,7 +3880,7 @@
             <a:r>
               <a:rPr lang="en-US" sz="1800" b="1" dirty="0">
                 <a:solidFill>
-                  <a:srgbClr val="2C5F2D"/>
+                  <a:srgbClr val="1E2761"/>
                 </a:solidFill>
                 <a:latin typeface="Georgia" pitchFamily="34" charset="0"/>
                 <a:ea typeface="Georgia" pitchFamily="34" charset="-122"/>
@@ -3920,7 +3920,7 @@
             <a:r>
               <a:rPr lang="en-US" sz="1300" dirty="0">
                 <a:solidFill>
-                  <a:srgbClr val="1A2E1A"/>
+                  <a:srgbClr val="0F172A"/>
                 </a:solidFill>
               </a:rPr>
               <a:t>PowerShell, Python, SQL</a:t>
@@ -3935,7 +3935,7 @@
             <a:r>
               <a:rPr lang="en-US" sz="1300" dirty="0">
                 <a:solidFill>
-                  <a:srgbClr val="1A2E1A"/>
+                  <a:srgbClr val="0F172A"/>
                 </a:solidFill>
               </a:rPr>
               <a:t>Power BI &amp; Tableau</a:t>
@@ -3950,7 +3950,7 @@
             <a:r>
               <a:rPr lang="en-US" sz="1300" dirty="0">
                 <a:solidFill>
-                  <a:srgbClr val="1A2E1A"/>
+                  <a:srgbClr val="0F172A"/>
                 </a:solidFill>
               </a:rPr>
               <a:t>Predictive Modeling</a:t>
@@ -3965,7 +3965,7 @@
             <a:r>
               <a:rPr lang="en-US" sz="1300" dirty="0">
                 <a:solidFill>
-                  <a:srgbClr val="1A2E1A"/>
+                  <a:srgbClr val="0F172A"/>
                 </a:solidFill>
               </a:rPr>
               <a:t>Workflow Automation</a:t>
@@ -3989,7 +3989,7 @@
             <a:avLst/>
           </a:prstGeom>
           <a:solidFill>
-            <a:srgbClr val="2C5F2D"/>
+            <a:srgbClr val="1E2761"/>
           </a:solidFill>
           <a:ln/>
         </p:spPr>
@@ -4021,7 +4021,7 @@
             <a:r>
               <a:rPr lang="en-US" sz="1000" dirty="0">
                 <a:solidFill>
-                  <a:srgbClr val="97BC62"/>
+                  <a:srgbClr val="CADCFC"/>
                 </a:solidFill>
               </a:rPr>
               <a:t>Tracey Scott  |  Cybersecurity • Cloud • SOC  |  traceysscott82@gmail.com</a:t>
@@ -4057,7 +4057,7 @@
             <a:r>
               <a:rPr lang="en-US" sz="1000" dirty="0">
                 <a:solidFill>
-                  <a:srgbClr val="97BC62"/>
+                  <a:srgbClr val="CADCFC"/>
                 </a:solidFill>
               </a:rPr>
               <a:t>3</a:t>
@@ -4080,7 +4080,7 @@
     <p:bg>
       <p:bgPr>
         <a:solidFill>
-          <a:srgbClr val="F5F5F5"/>
+          <a:srgbClr val="FFFFFF"/>
         </a:solidFill>
       </p:bgPr>
     </p:bg>
@@ -4125,7 +4125,7 @@
             <a:r>
               <a:rPr lang="en-US" sz="3600" b="1" dirty="0">
                 <a:solidFill>
-                  <a:srgbClr val="2C5F2D"/>
+                  <a:srgbClr val="1E2761"/>
                 </a:solidFill>
                 <a:latin typeface="Georgia" pitchFamily="34" charset="0"/>
                 <a:ea typeface="Georgia" pitchFamily="34" charset="-122"/>
@@ -4164,7 +4164,7 @@
             <a:r>
               <a:rPr lang="en-US" sz="1400" i="1" dirty="0">
                 <a:solidFill>
-                  <a:srgbClr val="6B7C5C"/>
+                  <a:srgbClr val="64748B"/>
                 </a:solidFill>
               </a:rPr>
               <a:t>Executive view I built at RightPath to monitor posture, incidents, and compliance.</a:t>
@@ -4188,7 +4188,7 @@
             <a:avLst/>
           </a:prstGeom>
           <a:solidFill>
-            <a:srgbClr val="2C5F2D"/>
+            <a:srgbClr val="1E2761"/>
           </a:solidFill>
           <a:ln/>
         </p:spPr>
@@ -4220,7 +4220,7 @@
             <a:r>
               <a:rPr lang="en-US" sz="3000" b="1" dirty="0">
                 <a:solidFill>
-                  <a:srgbClr val="D4A017"/>
+                  <a:srgbClr val="F59E0B"/>
                 </a:solidFill>
                 <a:latin typeface="Georgia" pitchFamily="34" charset="0"/>
                 <a:ea typeface="Georgia" pitchFamily="34" charset="-122"/>
@@ -4259,7 +4259,7 @@
             <a:r>
               <a:rPr lang="en-US" sz="1200" dirty="0">
                 <a:solidFill>
-                  <a:srgbClr val="97BC62"/>
+                  <a:srgbClr val="CADCFC"/>
                 </a:solidFill>
               </a:rPr>
               <a:t>Uptime</a:t>
@@ -4283,7 +4283,7 @@
             <a:avLst/>
           </a:prstGeom>
           <a:solidFill>
-            <a:srgbClr val="2C5F2D"/>
+            <a:srgbClr val="1E2761"/>
           </a:solidFill>
           <a:ln/>
         </p:spPr>
@@ -4315,7 +4315,7 @@
             <a:r>
               <a:rPr lang="en-US" sz="3000" b="1" dirty="0">
                 <a:solidFill>
-                  <a:srgbClr val="D4A017"/>
+                  <a:srgbClr val="F59E0B"/>
                 </a:solidFill>
                 <a:latin typeface="Georgia" pitchFamily="34" charset="0"/>
                 <a:ea typeface="Georgia" pitchFamily="34" charset="-122"/>
@@ -4354,7 +4354,7 @@
             <a:r>
               <a:rPr lang="en-US" sz="1200" dirty="0">
                 <a:solidFill>
-                  <a:srgbClr val="97BC62"/>
+                  <a:srgbClr val="CADCFC"/>
                 </a:solidFill>
               </a:rPr>
               <a:t>Critical Breaches</a:t>
@@ -4378,7 +4378,7 @@
             <a:avLst/>
           </a:prstGeom>
           <a:solidFill>
-            <a:srgbClr val="2C5F2D"/>
+            <a:srgbClr val="1E2761"/>
           </a:solidFill>
           <a:ln/>
         </p:spPr>
@@ -4410,7 +4410,7 @@
             <a:r>
               <a:rPr lang="en-US" sz="3000" b="1" dirty="0">
                 <a:solidFill>
-                  <a:srgbClr val="D4A017"/>
+                  <a:srgbClr val="F59E0B"/>
                 </a:solidFill>
                 <a:latin typeface="Georgia" pitchFamily="34" charset="0"/>
                 <a:ea typeface="Georgia" pitchFamily="34" charset="-122"/>
@@ -4449,7 +4449,7 @@
             <a:r>
               <a:rPr lang="en-US" sz="1200" dirty="0">
                 <a:solidFill>
-                  <a:srgbClr val="97BC62"/>
+                  <a:srgbClr val="CADCFC"/>
                 </a:solidFill>
               </a:rPr>
               <a:t>Threats Mitigated</a:t>
@@ -4473,7 +4473,7 @@
             <a:avLst/>
           </a:prstGeom>
           <a:solidFill>
-            <a:srgbClr val="2C5F2D"/>
+            <a:srgbClr val="1E2761"/>
           </a:solidFill>
           <a:ln/>
         </p:spPr>
@@ -4505,7 +4505,7 @@
             <a:r>
               <a:rPr lang="en-US" sz="3000" b="1" dirty="0">
                 <a:solidFill>
-                  <a:srgbClr val="D4A017"/>
+                  <a:srgbClr val="F59E0B"/>
                 </a:solidFill>
                 <a:latin typeface="Georgia" pitchFamily="34" charset="0"/>
                 <a:ea typeface="Georgia" pitchFamily="34" charset="-122"/>
@@ -4544,7 +4544,7 @@
             <a:r>
               <a:rPr lang="en-US" sz="1200" dirty="0">
                 <a:solidFill>
-                  <a:srgbClr val="97BC62"/>
+                  <a:srgbClr val="CADCFC"/>
                 </a:solidFill>
               </a:rPr>
               <a:t>RBAC Coverage</a:t>
@@ -4600,7 +4600,7 @@
             <a:avLst/>
           </a:prstGeom>
           <a:solidFill>
-            <a:srgbClr val="2C5F2D"/>
+            <a:srgbClr val="1E2761"/>
           </a:solidFill>
           <a:ln/>
         </p:spPr>
@@ -4632,7 +4632,7 @@
             <a:r>
               <a:rPr lang="en-US" sz="1000" dirty="0">
                 <a:solidFill>
-                  <a:srgbClr val="97BC62"/>
+                  <a:srgbClr val="CADCFC"/>
                 </a:solidFill>
               </a:rPr>
               <a:t>Tracey Scott  |  Cybersecurity • Cloud • SOC  |  traceysscott82@gmail.com</a:t>
@@ -4668,7 +4668,7 @@
             <a:r>
               <a:rPr lang="en-US" sz="1000" dirty="0">
                 <a:solidFill>
-                  <a:srgbClr val="97BC62"/>
+                  <a:srgbClr val="CADCFC"/>
                 </a:solidFill>
               </a:rPr>
               <a:t>4</a:t>
@@ -4691,7 +4691,7 @@
     <p:bg>
       <p:bgPr>
         <a:solidFill>
-          <a:srgbClr val="F5F5F5"/>
+          <a:srgbClr val="FFFFFF"/>
         </a:solidFill>
       </p:bgPr>
     </p:bg>
@@ -4736,7 +4736,7 @@
             <a:r>
               <a:rPr lang="en-US" sz="3600" b="1" dirty="0">
                 <a:solidFill>
-                  <a:srgbClr val="2C5F2D"/>
+                  <a:srgbClr val="1E2761"/>
                 </a:solidFill>
                 <a:latin typeface="Georgia" pitchFamily="34" charset="0"/>
                 <a:ea typeface="Georgia" pitchFamily="34" charset="-122"/>
@@ -4763,7 +4763,7 @@
             <a:avLst/>
           </a:prstGeom>
           <a:solidFill>
-            <a:srgbClr val="97BC62"/>
+            <a:srgbClr val="CADCFC"/>
           </a:solidFill>
           <a:ln/>
         </p:spPr>
@@ -4783,7 +4783,7 @@
             <a:avLst/>
           </a:prstGeom>
           <a:solidFill>
-            <a:srgbClr val="D4A017"/>
+            <a:srgbClr val="F59E0B"/>
           </a:solidFill>
           <a:ln/>
         </p:spPr>
@@ -4815,7 +4815,7 @@
             <a:r>
               <a:rPr lang="en-US" sz="1300" b="1" dirty="0">
                 <a:solidFill>
-                  <a:srgbClr val="D4A017"/>
+                  <a:srgbClr val="F59E0B"/>
                 </a:solidFill>
                 <a:latin typeface="Georgia" pitchFamily="34" charset="0"/>
                 <a:ea typeface="Georgia" pitchFamily="34" charset="-122"/>
@@ -4854,7 +4854,7 @@
             <a:r>
               <a:rPr lang="en-US" sz="1400" b="1" dirty="0">
                 <a:solidFill>
-                  <a:srgbClr val="2C5F2D"/>
+                  <a:srgbClr val="1E2761"/>
                 </a:solidFill>
               </a:rPr>
               <a:t>Enterprise Security Framework</a:t>
@@ -4890,7 +4890,7 @@
             <a:r>
               <a:rPr lang="en-US" sz="1100" dirty="0">
                 <a:solidFill>
-                  <a:srgbClr val="1A2E1A"/>
+                  <a:srgbClr val="0F172A"/>
                 </a:solidFill>
               </a:rPr>
               <a:t>Architected endpoint, IDS/IPS, MDM, and access governance for startup in 6 months.</a:t>
@@ -4914,7 +4914,7 @@
             <a:avLst/>
           </a:prstGeom>
           <a:solidFill>
-            <a:srgbClr val="97BC62"/>
+            <a:srgbClr val="CADCFC"/>
           </a:solidFill>
           <a:ln/>
         </p:spPr>
@@ -4934,7 +4934,7 @@
             <a:avLst/>
           </a:prstGeom>
           <a:solidFill>
-            <a:srgbClr val="D4A017"/>
+            <a:srgbClr val="F59E0B"/>
           </a:solidFill>
           <a:ln/>
         </p:spPr>
@@ -4966,7 +4966,7 @@
             <a:r>
               <a:rPr lang="en-US" sz="1300" b="1" dirty="0">
                 <a:solidFill>
-                  <a:srgbClr val="D4A017"/>
+                  <a:srgbClr val="F59E0B"/>
                 </a:solidFill>
                 <a:latin typeface="Georgia" pitchFamily="34" charset="0"/>
                 <a:ea typeface="Georgia" pitchFamily="34" charset="-122"/>
@@ -5005,7 +5005,7 @@
             <a:r>
               <a:rPr lang="en-US" sz="1400" b="1" dirty="0">
                 <a:solidFill>
-                  <a:srgbClr val="2C5F2D"/>
+                  <a:srgbClr val="1E2761"/>
                 </a:solidFill>
               </a:rPr>
               <a:t>Secure Multi-Cloud Deployment</a:t>
@@ -5041,7 +5041,7 @@
             <a:r>
               <a:rPr lang="en-US" sz="1100" dirty="0">
                 <a:solidFill>
-                  <a:srgbClr val="1A2E1A"/>
+                  <a:srgbClr val="0F172A"/>
                 </a:solidFill>
               </a:rPr>
               <a:t>AWS + Azure infrastructure with IAM, RBAC, encryption, and least-privilege controls.</a:t>
@@ -5065,7 +5065,7 @@
             <a:avLst/>
           </a:prstGeom>
           <a:solidFill>
-            <a:srgbClr val="97BC62"/>
+            <a:srgbClr val="CADCFC"/>
           </a:solidFill>
           <a:ln/>
         </p:spPr>
@@ -5085,7 +5085,7 @@
             <a:avLst/>
           </a:prstGeom>
           <a:solidFill>
-            <a:srgbClr val="D4A017"/>
+            <a:srgbClr val="F59E0B"/>
           </a:solidFill>
           <a:ln/>
         </p:spPr>
@@ -5117,7 +5117,7 @@
             <a:r>
               <a:rPr lang="en-US" sz="1300" b="1" dirty="0">
                 <a:solidFill>
-                  <a:srgbClr val="D4A017"/>
+                  <a:srgbClr val="F59E0B"/>
                 </a:solidFill>
                 <a:latin typeface="Georgia" pitchFamily="34" charset="0"/>
                 <a:ea typeface="Georgia" pitchFamily="34" charset="-122"/>
@@ -5156,7 +5156,7 @@
             <a:r>
               <a:rPr lang="en-US" sz="1400" b="1" dirty="0">
                 <a:solidFill>
-                  <a:srgbClr val="2C5F2D"/>
+                  <a:srgbClr val="1E2761"/>
                 </a:solidFill>
               </a:rPr>
               <a:t>CRM Secure Deployment</a:t>
@@ -5192,7 +5192,7 @@
             <a:r>
               <a:rPr lang="en-US" sz="1100" dirty="0">
                 <a:solidFill>
-                  <a:srgbClr val="1A2E1A"/>
+                  <a:srgbClr val="0F172A"/>
                 </a:solidFill>
               </a:rPr>
               <a:t>Led CRM configuration with secure auth, encryption, and role-based permissions.</a:t>
@@ -5216,7 +5216,7 @@
             <a:avLst/>
           </a:prstGeom>
           <a:solidFill>
-            <a:srgbClr val="97BC62"/>
+            <a:srgbClr val="CADCFC"/>
           </a:solidFill>
           <a:ln/>
         </p:spPr>
@@ -5236,7 +5236,7 @@
             <a:avLst/>
           </a:prstGeom>
           <a:solidFill>
-            <a:srgbClr val="D4A017"/>
+            <a:srgbClr val="F59E0B"/>
           </a:solidFill>
           <a:ln/>
         </p:spPr>
@@ -5268,7 +5268,7 @@
             <a:r>
               <a:rPr lang="en-US" sz="1300" b="1" dirty="0">
                 <a:solidFill>
-                  <a:srgbClr val="D4A017"/>
+                  <a:srgbClr val="F59E0B"/>
                 </a:solidFill>
                 <a:latin typeface="Georgia" pitchFamily="34" charset="0"/>
                 <a:ea typeface="Georgia" pitchFamily="34" charset="-122"/>
@@ -5307,7 +5307,7 @@
             <a:r>
               <a:rPr lang="en-US" sz="1400" b="1" dirty="0">
                 <a:solidFill>
-                  <a:srgbClr val="2C5F2D"/>
+                  <a:srgbClr val="1E2761"/>
                 </a:solidFill>
               </a:rPr>
               <a:t>Executive Dashboards</a:t>
@@ -5343,7 +5343,7 @@
             <a:r>
               <a:rPr lang="en-US" sz="1100" dirty="0">
                 <a:solidFill>
-                  <a:srgbClr val="1A2E1A"/>
+                  <a:srgbClr val="0F172A"/>
                 </a:solidFill>
               </a:rPr>
               <a:t>Built Power BI dashboards for incidents, access activity, and compliance metrics.</a:t>
@@ -5367,7 +5367,7 @@
             <a:avLst/>
           </a:prstGeom>
           <a:solidFill>
-            <a:srgbClr val="97BC62"/>
+            <a:srgbClr val="CADCFC"/>
           </a:solidFill>
           <a:ln/>
         </p:spPr>
@@ -5387,7 +5387,7 @@
             <a:avLst/>
           </a:prstGeom>
           <a:solidFill>
-            <a:srgbClr val="D4A017"/>
+            <a:srgbClr val="F59E0B"/>
           </a:solidFill>
           <a:ln/>
         </p:spPr>
@@ -5419,7 +5419,7 @@
             <a:r>
               <a:rPr lang="en-US" sz="1300" b="1" dirty="0">
                 <a:solidFill>
-                  <a:srgbClr val="D4A017"/>
+                  <a:srgbClr val="F59E0B"/>
                 </a:solidFill>
                 <a:latin typeface="Georgia" pitchFamily="34" charset="0"/>
                 <a:ea typeface="Georgia" pitchFamily="34" charset="-122"/>
@@ -5458,7 +5458,7 @@
             <a:r>
               <a:rPr lang="en-US" sz="1400" b="1" dirty="0">
                 <a:solidFill>
-                  <a:srgbClr val="2C5F2D"/>
+                  <a:srgbClr val="1E2761"/>
                 </a:solidFill>
               </a:rPr>
               <a:t>Incident Response Program</a:t>
@@ -5494,7 +5494,7 @@
             <a:r>
               <a:rPr lang="en-US" sz="1100" dirty="0">
                 <a:solidFill>
-                  <a:srgbClr val="1A2E1A"/>
+                  <a:srgbClr val="0F172A"/>
                 </a:solidFill>
               </a:rPr>
               <a:t>Developed IR documentation, escalation playbooks, and remediation workflows.</a:t>
@@ -5518,7 +5518,7 @@
             <a:avLst/>
           </a:prstGeom>
           <a:solidFill>
-            <a:srgbClr val="97BC62"/>
+            <a:srgbClr val="CADCFC"/>
           </a:solidFill>
           <a:ln/>
         </p:spPr>
@@ -5538,7 +5538,7 @@
             <a:avLst/>
           </a:prstGeom>
           <a:solidFill>
-            <a:srgbClr val="D4A017"/>
+            <a:srgbClr val="F59E0B"/>
           </a:solidFill>
           <a:ln/>
         </p:spPr>
@@ -5570,7 +5570,7 @@
             <a:r>
               <a:rPr lang="en-US" sz="1300" b="1" dirty="0">
                 <a:solidFill>
-                  <a:srgbClr val="D4A017"/>
+                  <a:srgbClr val="F59E0B"/>
                 </a:solidFill>
                 <a:latin typeface="Georgia" pitchFamily="34" charset="0"/>
                 <a:ea typeface="Georgia" pitchFamily="34" charset="-122"/>
@@ -5609,7 +5609,7 @@
             <a:r>
               <a:rPr lang="en-US" sz="1400" b="1" dirty="0">
                 <a:solidFill>
-                  <a:srgbClr val="2C5F2D"/>
+                  <a:srgbClr val="1E2761"/>
                 </a:solidFill>
               </a:rPr>
               <a:t>DR &amp; Business Continuity</a:t>
@@ -5645,7 +5645,7 @@
             <a:r>
               <a:rPr lang="en-US" sz="1100" dirty="0">
                 <a:solidFill>
-                  <a:srgbClr val="1A2E1A"/>
+                  <a:srgbClr val="0F172A"/>
                 </a:solidFill>
               </a:rPr>
               <a:t>Backup, disaster recovery, and BCP procedures for hybrid infrastructure.</a:t>
@@ -5669,7 +5669,7 @@
             <a:avLst/>
           </a:prstGeom>
           <a:solidFill>
-            <a:srgbClr val="97BC62"/>
+            <a:srgbClr val="CADCFC"/>
           </a:solidFill>
           <a:ln/>
         </p:spPr>
@@ -5689,7 +5689,7 @@
             <a:avLst/>
           </a:prstGeom>
           <a:solidFill>
-            <a:srgbClr val="D4A017"/>
+            <a:srgbClr val="F59E0B"/>
           </a:solidFill>
           <a:ln/>
         </p:spPr>
@@ -5721,7 +5721,7 @@
             <a:r>
               <a:rPr lang="en-US" sz="1300" b="1" dirty="0">
                 <a:solidFill>
-                  <a:srgbClr val="D4A017"/>
+                  <a:srgbClr val="F59E0B"/>
                 </a:solidFill>
                 <a:latin typeface="Georgia" pitchFamily="34" charset="0"/>
                 <a:ea typeface="Georgia" pitchFamily="34" charset="-122"/>
@@ -5760,7 +5760,7 @@
             <a:r>
               <a:rPr lang="en-US" sz="1400" b="1" dirty="0">
                 <a:solidFill>
-                  <a:srgbClr val="2C5F2D"/>
+                  <a:srgbClr val="1E2761"/>
                 </a:solidFill>
               </a:rPr>
               <a:t>Internal AI Chatbots</a:t>
@@ -5796,7 +5796,7 @@
             <a:r>
               <a:rPr lang="en-US" sz="1100" dirty="0">
                 <a:solidFill>
-                  <a:srgbClr val="1A2E1A"/>
+                  <a:srgbClr val="0F172A"/>
                 </a:solidFill>
               </a:rPr>
               <a:t>Built AI chatbots for multiple departments with CRM, Microsoft 365, and SharePoint connectivity.</a:t>
@@ -5820,7 +5820,7 @@
             <a:avLst/>
           </a:prstGeom>
           <a:solidFill>
-            <a:srgbClr val="2C5F2D"/>
+            <a:srgbClr val="1E2761"/>
           </a:solidFill>
           <a:ln/>
         </p:spPr>
@@ -5852,7 +5852,7 @@
             <a:r>
               <a:rPr lang="en-US" sz="1000" dirty="0">
                 <a:solidFill>
-                  <a:srgbClr val="97BC62"/>
+                  <a:srgbClr val="CADCFC"/>
                 </a:solidFill>
               </a:rPr>
               <a:t>Tracey Scott  |  Cybersecurity • Cloud • SOC  |  traceysscott82@gmail.com</a:t>
@@ -5888,7 +5888,7 @@
             <a:r>
               <a:rPr lang="en-US" sz="1000" dirty="0">
                 <a:solidFill>
-                  <a:srgbClr val="97BC62"/>
+                  <a:srgbClr val="CADCFC"/>
                 </a:solidFill>
               </a:rPr>
               <a:t>5</a:t>
@@ -5911,7 +5911,7 @@
     <p:bg>
       <p:bgPr>
         <a:solidFill>
-          <a:srgbClr val="F5F5F5"/>
+          <a:srgbClr val="FFFFFF"/>
         </a:solidFill>
       </p:bgPr>
     </p:bg>
@@ -5956,7 +5956,7 @@
             <a:r>
               <a:rPr lang="en-US" sz="3600" b="1" dirty="0">
                 <a:solidFill>
-                  <a:srgbClr val="2C5F2D"/>
+                  <a:srgbClr val="1E2761"/>
                 </a:solidFill>
                 <a:latin typeface="Georgia" pitchFamily="34" charset="0"/>
                 <a:ea typeface="Georgia" pitchFamily="34" charset="-122"/>
@@ -5995,7 +5995,7 @@
             <a:r>
               <a:rPr lang="en-US" sz="1400" i="1" dirty="0">
                 <a:solidFill>
-                  <a:srgbClr val="6B7C5C"/>
+                  <a:srgbClr val="64748B"/>
                 </a:solidFill>
               </a:rPr>
               <a:t>Self-assessed proficiency across the stack I use in production.</a:t>
@@ -6035,7 +6035,7 @@
             <a:avLst/>
           </a:prstGeom>
           <a:solidFill>
-            <a:srgbClr val="2C5F2D"/>
+            <a:srgbClr val="1E2761"/>
           </a:solidFill>
           <a:ln/>
         </p:spPr>
@@ -6067,7 +6067,7 @@
             <a:r>
               <a:rPr lang="en-US" sz="1000" dirty="0">
                 <a:solidFill>
-                  <a:srgbClr val="97BC62"/>
+                  <a:srgbClr val="CADCFC"/>
                 </a:solidFill>
               </a:rPr>
               <a:t>Tracey Scott  |  Cybersecurity • Cloud • SOC  |  traceysscott82@gmail.com</a:t>
@@ -6103,7 +6103,7 @@
             <a:r>
               <a:rPr lang="en-US" sz="1000" dirty="0">
                 <a:solidFill>
-                  <a:srgbClr val="97BC62"/>
+                  <a:srgbClr val="CADCFC"/>
                 </a:solidFill>
               </a:rPr>
               <a:t>6</a:t>
@@ -6126,7 +6126,7 @@
     <p:bg>
       <p:bgPr>
         <a:solidFill>
-          <a:srgbClr val="2C5F2D"/>
+          <a:srgbClr val="1E2761"/>
         </a:solidFill>
       </p:bgPr>
     </p:bg>
@@ -6171,7 +6171,7 @@
             <a:r>
               <a:rPr lang="en-US" sz="3600" b="1" dirty="0">
                 <a:solidFill>
-                  <a:srgbClr val="F5F5F5"/>
+                  <a:srgbClr val="FFFFFF"/>
                 </a:solidFill>
                 <a:latin typeface="Georgia" pitchFamily="34" charset="0"/>
                 <a:ea typeface="Georgia" pitchFamily="34" charset="-122"/>
@@ -6198,7 +6198,7 @@
             <a:avLst/>
           </a:prstGeom>
           <a:solidFill>
-            <a:srgbClr val="D4A017"/>
+            <a:srgbClr val="F59E0B"/>
           </a:solidFill>
           <a:ln/>
         </p:spPr>
@@ -6218,13 +6218,13 @@
             <a:avLst/>
           </a:prstGeom>
           <a:solidFill>
-            <a:srgbClr val="F5F5F5">
+            <a:srgbClr val="FFFFFF">
               <a:alpha val="10000"/>
             </a:srgbClr>
           </a:solidFill>
           <a:ln w="12700">
             <a:solidFill>
-              <a:srgbClr val="97BC62"/>
+              <a:srgbClr val="CADCFC"/>
             </a:solidFill>
             <a:prstDash val="solid"/>
           </a:ln>
@@ -6257,7 +6257,7 @@
             <a:r>
               <a:rPr lang="en-US" sz="4400" b="1" dirty="0">
                 <a:solidFill>
-                  <a:srgbClr val="D4A017"/>
+                  <a:srgbClr val="F59E0B"/>
                 </a:solidFill>
                 <a:latin typeface="Georgia" pitchFamily="34" charset="0"/>
                 <a:ea typeface="Georgia" pitchFamily="34" charset="-122"/>
@@ -6296,7 +6296,7 @@
             <a:r>
               <a:rPr lang="en-US" sz="1300" dirty="0">
                 <a:solidFill>
-                  <a:srgbClr val="F5F5F5"/>
+                  <a:srgbClr val="FFFFFF"/>
                 </a:solidFill>
               </a:rPr>
               <a:t>Full security framework stood up from zero</a:t>
@@ -6320,13 +6320,13 @@
             <a:avLst/>
           </a:prstGeom>
           <a:solidFill>
-            <a:srgbClr val="F5F5F5">
+            <a:srgbClr val="FFFFFF">
               <a:alpha val="10000"/>
             </a:srgbClr>
           </a:solidFill>
           <a:ln w="12700">
             <a:solidFill>
-              <a:srgbClr val="97BC62"/>
+              <a:srgbClr val="CADCFC"/>
             </a:solidFill>
             <a:prstDash val="solid"/>
           </a:ln>
@@ -6359,7 +6359,7 @@
             <a:r>
               <a:rPr lang="en-US" sz="4400" b="1" dirty="0">
                 <a:solidFill>
-                  <a:srgbClr val="D4A017"/>
+                  <a:srgbClr val="F59E0B"/>
                 </a:solidFill>
                 <a:latin typeface="Georgia" pitchFamily="34" charset="0"/>
                 <a:ea typeface="Georgia" pitchFamily="34" charset="-122"/>
@@ -6398,7 +6398,7 @@
             <a:r>
               <a:rPr lang="en-US" sz="1300" dirty="0">
                 <a:solidFill>
-                  <a:srgbClr val="F5F5F5"/>
+                  <a:srgbClr val="FFFFFF"/>
                 </a:solidFill>
               </a:rPr>
               <a:t>Predictive model accuracy delivered to stakeholders</a:t>
@@ -6422,13 +6422,13 @@
             <a:avLst/>
           </a:prstGeom>
           <a:solidFill>
-            <a:srgbClr val="F5F5F5">
+            <a:srgbClr val="FFFFFF">
               <a:alpha val="10000"/>
             </a:srgbClr>
           </a:solidFill>
           <a:ln w="12700">
             <a:solidFill>
-              <a:srgbClr val="97BC62"/>
+              <a:srgbClr val="CADCFC"/>
             </a:solidFill>
             <a:prstDash val="solid"/>
           </a:ln>
@@ -6461,7 +6461,7 @@
             <a:r>
               <a:rPr lang="en-US" sz="4400" b="1" dirty="0">
                 <a:solidFill>
-                  <a:srgbClr val="D4A017"/>
+                  <a:srgbClr val="F59E0B"/>
                 </a:solidFill>
                 <a:latin typeface="Georgia" pitchFamily="34" charset="0"/>
                 <a:ea typeface="Georgia" pitchFamily="34" charset="-122"/>
@@ -6500,7 +6500,7 @@
             <a:r>
               <a:rPr lang="en-US" sz="1300" dirty="0">
                 <a:solidFill>
-                  <a:srgbClr val="F5F5F5"/>
+                  <a:srgbClr val="FFFFFF"/>
                 </a:solidFill>
               </a:rPr>
               <a:t>Reporting accuracy gain through data validation</a:t>
@@ -6524,13 +6524,13 @@
             <a:avLst/>
           </a:prstGeom>
           <a:solidFill>
-            <a:srgbClr val="F5F5F5">
+            <a:srgbClr val="FFFFFF">
               <a:alpha val="10000"/>
             </a:srgbClr>
           </a:solidFill>
           <a:ln w="12700">
             <a:solidFill>
-              <a:srgbClr val="97BC62"/>
+              <a:srgbClr val="CADCFC"/>
             </a:solidFill>
             <a:prstDash val="solid"/>
           </a:ln>
@@ -6563,7 +6563,7 @@
             <a:r>
               <a:rPr lang="en-US" sz="4400" b="1" dirty="0">
                 <a:solidFill>
-                  <a:srgbClr val="D4A017"/>
+                  <a:srgbClr val="F59E0B"/>
                 </a:solidFill>
                 <a:latin typeface="Georgia" pitchFamily="34" charset="0"/>
                 <a:ea typeface="Georgia" pitchFamily="34" charset="-122"/>
@@ -6602,7 +6602,7 @@
             <a:r>
               <a:rPr lang="en-US" sz="1300" dirty="0">
                 <a:solidFill>
-                  <a:srgbClr val="F5F5F5"/>
+                  <a:srgbClr val="FFFFFF"/>
                 </a:solidFill>
               </a:rPr>
               <a:t>RBAC / least-privilege coverage across hybrid env</a:t>
@@ -6626,13 +6626,13 @@
             <a:avLst/>
           </a:prstGeom>
           <a:solidFill>
-            <a:srgbClr val="F5F5F5">
+            <a:srgbClr val="FFFFFF">
               <a:alpha val="10000"/>
             </a:srgbClr>
           </a:solidFill>
           <a:ln w="12700">
             <a:solidFill>
-              <a:srgbClr val="97BC62"/>
+              <a:srgbClr val="CADCFC"/>
             </a:solidFill>
             <a:prstDash val="solid"/>
           </a:ln>
@@ -6665,7 +6665,7 @@
             <a:r>
               <a:rPr lang="en-US" sz="4400" b="1" dirty="0">
                 <a:solidFill>
-                  <a:srgbClr val="D4A017"/>
+                  <a:srgbClr val="F59E0B"/>
                 </a:solidFill>
                 <a:latin typeface="Georgia" pitchFamily="34" charset="0"/>
                 <a:ea typeface="Georgia" pitchFamily="34" charset="-122"/>
@@ -6704,7 +6704,7 @@
             <a:r>
               <a:rPr lang="en-US" sz="1300" dirty="0">
                 <a:solidFill>
-                  <a:srgbClr val="F5F5F5"/>
+                  <a:srgbClr val="FFFFFF"/>
                 </a:solidFill>
               </a:rPr>
               <a:t>Critical incidents since framework rollout</a:t>
@@ -6728,13 +6728,13 @@
             <a:avLst/>
           </a:prstGeom>
           <a:solidFill>
-            <a:srgbClr val="F5F5F5">
+            <a:srgbClr val="FFFFFF">
               <a:alpha val="10000"/>
             </a:srgbClr>
           </a:solidFill>
           <a:ln w="12700">
             <a:solidFill>
-              <a:srgbClr val="97BC62"/>
+              <a:srgbClr val="CADCFC"/>
             </a:solidFill>
             <a:prstDash val="solid"/>
           </a:ln>
@@ -6767,7 +6767,7 @@
             <a:r>
               <a:rPr lang="en-US" sz="4400" b="1" dirty="0">
                 <a:solidFill>
-                  <a:srgbClr val="D4A017"/>
+                  <a:srgbClr val="F59E0B"/>
                 </a:solidFill>
                 <a:latin typeface="Georgia" pitchFamily="34" charset="0"/>
                 <a:ea typeface="Georgia" pitchFamily="34" charset="-122"/>
@@ -6806,7 +6806,7 @@
             <a:r>
               <a:rPr lang="en-US" sz="1300" dirty="0">
                 <a:solidFill>
-                  <a:srgbClr val="F5F5F5"/>
+                  <a:srgbClr val="FFFFFF"/>
                 </a:solidFill>
               </a:rPr>
               <a:t>Public clouds secured and administered (AWS/Azure/GCP)</a:t>
@@ -6830,7 +6830,7 @@
             <a:avLst/>
           </a:prstGeom>
           <a:solidFill>
-            <a:srgbClr val="2C5F2D"/>
+            <a:srgbClr val="1E2761"/>
           </a:solidFill>
           <a:ln/>
         </p:spPr>
@@ -6862,7 +6862,7 @@
             <a:r>
               <a:rPr lang="en-US" sz="1000" dirty="0">
                 <a:solidFill>
-                  <a:srgbClr val="97BC62"/>
+                  <a:srgbClr val="CADCFC"/>
                 </a:solidFill>
               </a:rPr>
               <a:t>Tracey Scott  |  Cybersecurity • Cloud • SOC  |  traceysscott82@gmail.com</a:t>
@@ -6898,7 +6898,7 @@
             <a:r>
               <a:rPr lang="en-US" sz="1000" dirty="0">
                 <a:solidFill>
-                  <a:srgbClr val="97BC62"/>
+                  <a:srgbClr val="CADCFC"/>
                 </a:solidFill>
               </a:rPr>
               <a:t>7</a:t>
@@ -6921,7 +6921,7 @@
     <p:bg>
       <p:bgPr>
         <a:solidFill>
-          <a:srgbClr val="F5F5F5"/>
+          <a:srgbClr val="FFFFFF"/>
         </a:solidFill>
       </p:bgPr>
     </p:bg>
@@ -6966,7 +6966,7 @@
             <a:r>
               <a:rPr lang="en-US" sz="4000" b="1" dirty="0">
                 <a:solidFill>
-                  <a:srgbClr val="2C5F2D"/>
+                  <a:srgbClr val="1E2761"/>
                 </a:solidFill>
                 <a:latin typeface="Georgia" pitchFamily="34" charset="0"/>
                 <a:ea typeface="Georgia" pitchFamily="34" charset="-122"/>
@@ -6993,7 +6993,7 @@
             <a:avLst/>
           </a:prstGeom>
           <a:solidFill>
-            <a:srgbClr val="97BC62"/>
+            <a:srgbClr val="CADCFC"/>
           </a:solidFill>
           <a:ln/>
         </p:spPr>
@@ -7025,7 +7025,7 @@
             <a:r>
               <a:rPr lang="en-US" sz="2000" b="1" dirty="0">
                 <a:solidFill>
-                  <a:srgbClr val="2C5F2D"/>
+                  <a:srgbClr val="1E2761"/>
                 </a:solidFill>
               </a:rPr>
               <a:t>Professional Goals</a:t>
@@ -7065,7 +7065,7 @@
             <a:r>
               <a:rPr lang="en-US" sz="1500" dirty="0">
                 <a:solidFill>
-                  <a:srgbClr val="1A2E1A"/>
+                  <a:srgbClr val="0F172A"/>
                 </a:solidFill>
               </a:rPr>
               <a:t>Earn CISSP certification (in progress)</a:t>
@@ -7083,7 +7083,7 @@
             <a:r>
               <a:rPr lang="en-US" sz="1500" dirty="0">
                 <a:solidFill>
-                  <a:srgbClr val="1A2E1A"/>
+                  <a:srgbClr val="0F172A"/>
                 </a:solidFill>
               </a:rPr>
               <a:t>Lead a cybersecurity operations team or SOC</a:t>
@@ -7101,7 +7101,7 @@
             <a:r>
               <a:rPr lang="en-US" sz="1500" dirty="0">
                 <a:solidFill>
-                  <a:srgbClr val="1A2E1A"/>
+                  <a:srgbClr val="0F172A"/>
                 </a:solidFill>
               </a:rPr>
               <a:t>Deepen cloud security automation &amp; IaC practice</a:t>
@@ -7119,7 +7119,7 @@
             <a:r>
               <a:rPr lang="en-US" sz="1500" dirty="0">
                 <a:solidFill>
-                  <a:srgbClr val="1A2E1A"/>
+                  <a:srgbClr val="0F172A"/>
                 </a:solidFill>
               </a:rPr>
               <a:t>Mentor women entering cybersecurity via RTC &amp; ISSA</a:t>
@@ -7134,7 +7134,7 @@
             <a:r>
               <a:rPr lang="en-US" sz="1500" dirty="0">
                 <a:solidFill>
-                  <a:srgbClr val="1A2E1A"/>
+                  <a:srgbClr val="0F172A"/>
                 </a:solidFill>
               </a:rPr>
               <a:t>Contribute to enterprise zero-trust architecture</a:t>
@@ -7158,7 +7158,7 @@
             <a:avLst/>
           </a:prstGeom>
           <a:solidFill>
-            <a:srgbClr val="2C5F2D"/>
+            <a:srgbClr val="1E2761"/>
           </a:solidFill>
           <a:ln/>
         </p:spPr>
@@ -7178,7 +7178,7 @@
             <a:avLst/>
           </a:prstGeom>
           <a:solidFill>
-            <a:srgbClr val="D4A017"/>
+            <a:srgbClr val="F59E0B"/>
           </a:solidFill>
           <a:ln/>
         </p:spPr>
@@ -7210,7 +7210,7 @@
             <a:r>
               <a:rPr lang="en-US" sz="2400" b="1" dirty="0">
                 <a:solidFill>
-                  <a:srgbClr val="F5F5F5"/>
+                  <a:srgbClr val="FFFFFF"/>
                 </a:solidFill>
                 <a:latin typeface="Georgia" pitchFamily="34" charset="0"/>
                 <a:ea typeface="Georgia" pitchFamily="34" charset="-122"/>
@@ -7252,7 +7252,7 @@
             <a:r>
               <a:rPr lang="en-US" sz="1800" b="1" dirty="0">
                 <a:solidFill>
-                  <a:srgbClr val="D4A017"/>
+                  <a:srgbClr val="F59E0B"/>
                 </a:solidFill>
               </a:rPr>
               <a:t>Tracey Scott</a:t>
@@ -7269,7 +7269,7 @@
             <a:r>
               <a:rPr lang="en-US" sz="1400" i="1" dirty="0">
                 <a:solidFill>
-                  <a:srgbClr val="97BC62"/>
+                  <a:srgbClr val="CADCFC"/>
                 </a:solidFill>
               </a:rPr>
               <a:t>IT Operations Manager &amp; Business Analyst</a:t>
@@ -7286,7 +7286,7 @@
             <a:r>
               <a:rPr lang="en-US" sz="1400" dirty="0">
                 <a:solidFill>
-                  <a:srgbClr val="F5F5F5"/>
+                  <a:srgbClr val="FFFFFF"/>
                 </a:solidFill>
               </a:rPr>
               <a:t>Greenville, SC</a:t>
@@ -7303,7 +7303,7 @@
             <a:r>
               <a:rPr lang="en-US" sz="1400" dirty="0">
                 <a:solidFill>
-                  <a:srgbClr val="F5F5F5"/>
+                  <a:srgbClr val="FFFFFF"/>
                 </a:solidFill>
               </a:rPr>
               <a:t>(864) 775-2929</a:t>
@@ -7320,7 +7320,7 @@
             <a:r>
               <a:rPr lang="en-US" sz="1400" dirty="0">
                 <a:solidFill>
-                  <a:srgbClr val="F5F5F5"/>
+                  <a:srgbClr val="FFFFFF"/>
                 </a:solidFill>
               </a:rPr>
               <a:t>traceysscott82@gmail.com</a:t>
@@ -7337,7 +7337,7 @@
             <a:r>
               <a:rPr lang="en-US" sz="1400" dirty="0">
                 <a:solidFill>
-                  <a:srgbClr val="F5F5F5"/>
+                  <a:srgbClr val="FFFFFF"/>
                 </a:solidFill>
               </a:rPr>
               <a:t>linkedin.com/in/traceysscott</a:t>
@@ -7351,7 +7351,7 @@
             <a:r>
               <a:rPr lang="en-US" sz="1400" b="1" dirty="0">
                 <a:solidFill>
-                  <a:srgbClr val="D4A017"/>
+                  <a:srgbClr val="F59E0B"/>
                 </a:solidFill>
               </a:rPr>
               <a:t>traceytheanalyst.github.io</a:t>
@@ -7375,7 +7375,7 @@
             <a:avLst/>
           </a:prstGeom>
           <a:solidFill>
-            <a:srgbClr val="2C5F2D"/>
+            <a:srgbClr val="1E2761"/>
           </a:solidFill>
           <a:ln/>
         </p:spPr>
@@ -7407,7 +7407,7 @@
             <a:r>
               <a:rPr lang="en-US" sz="1000" dirty="0">
                 <a:solidFill>
-                  <a:srgbClr val="97BC62"/>
+                  <a:srgbClr val="CADCFC"/>
                 </a:solidFill>
               </a:rPr>
               <a:t>Tracey Scott  |  Cybersecurity • Cloud • SOC  |  traceysscott82@gmail.com</a:t>
@@ -7443,7 +7443,7 @@
             <a:r>
               <a:rPr lang="en-US" sz="1000" dirty="0">
                 <a:solidFill>
-                  <a:srgbClr val="97BC62"/>
+                  <a:srgbClr val="CADCFC"/>
                 </a:solidFill>
               </a:rPr>
               <a:t>8</a:t>

</xml_diff>

<commit_message>
Update content: 4+ years, CISSP earned, KnowBe4, LLM, IT ticketing, dashboards
</commit_message>
<xml_diff>
--- a/Tracey-Scott-Portfolio.pptx
+++ b/Tracey-Scott-Portfolio.pptx
@@ -714,7 +714,7 @@
                     <c:v>IDS/IPS</c:v>
                   </c:pt>
                   <c:pt idx="3">
-                    <c:v>SIEM/Log Analysis</c:v>
+                    <c:v>LLM / Machine Learning</c:v>
                   </c:pt>
                   <c:pt idx="4">
                     <c:v>Python/SQL</c:v>
@@ -723,7 +723,7 @@
                     <c:v>Power BI</c:v>
                   </c:pt>
                   <c:pt idx="6">
-                    <c:v>PowerShell</c:v>
+                    <c:v>Excel</c:v>
                   </c:pt>
                   <c:pt idx="7">
                     <c:v>Virtualization</c:v>
@@ -748,7 +748,7 @@
                   <c:v>88</c:v>
                 </c:pt>
                 <c:pt idx="3">
-                  <c:v>85</c:v>
+                  <c:v>84</c:v>
                 </c:pt>
                 <c:pt idx="4">
                   <c:v>90</c:v>
@@ -757,7 +757,7 @@
                   <c:v>93</c:v>
                 </c:pt>
                 <c:pt idx="6">
-                  <c:v>87</c:v>
+                  <c:v>95</c:v>
                 </c:pt>
                 <c:pt idx="7">
                   <c:v>86</c:v>
@@ -2616,7 +2616,7 @@
                 <a:ea typeface="Calibri" pitchFamily="34" charset="-122"/>
                 <a:cs typeface="Calibri" pitchFamily="34" charset="-120"/>
               </a:rPr>
-              <a:t>Cybersecurity-focused IT leader with 3+ years building and securing enterprise cloud and hybrid infrastructure in fast-paced startup environments.</a:t>
+              <a:t>Cybersecurity-focused IT leader with 4+ years building and securing enterprise cloud and hybrid infrastructure in fast-paced startup environments.</a:t>
             </a:r>
             <a:endParaRPr lang="en-US" sz="1500" dirty="0"/>
           </a:p>
@@ -2653,7 +2653,7 @@
                 <a:ea typeface="Calibri" pitchFamily="34" charset="-122"/>
                 <a:cs typeface="Calibri" pitchFamily="34" charset="-120"/>
               </a:rPr>
-              <a:t>Currently leading IT Operations at RightPath Insurance and CISSP-certified.</a:t>
+              <a:t>Currently leading IT Operations at RightPath Insurance, Cybersecurity and CISSP - certified.</a:t>
             </a:r>
             <a:endParaRPr lang="en-US" sz="1500" dirty="0"/>
           </a:p>
@@ -2732,7 +2732,7 @@
                 <a:ea typeface="Georgia" pitchFamily="34" charset="-122"/>
                 <a:cs typeface="Georgia" pitchFamily="34" charset="-120"/>
               </a:rPr>
-              <a:t>3+</a:t>
+              <a:t>4+</a:t>
             </a:r>
             <a:endParaRPr lang="en-US" sz="4800" dirty="0"/>
           </a:p>
@@ -3449,7 +3449,7 @@
                   <a:srgbClr val="0F172A"/>
                 </a:solidFill>
               </a:rPr>
-              <a:t>Log Analysis &amp; SIEM</a:t>
+              <a:t>Org Training via KnowBe4</a:t>
             </a:r>
             <a:endParaRPr lang="en-US" sz="1300" dirty="0"/>
           </a:p>
@@ -3938,7 +3938,7 @@
                   <a:srgbClr val="0F172A"/>
                 </a:solidFill>
               </a:rPr>
-              <a:t>Power BI &amp; Tableau</a:t>
+              <a:t>Excel (Pivot Tables, VLOOKUP)</a:t>
             </a:r>
             <a:endParaRPr lang="en-US" sz="1300" dirty="0"/>
           </a:p>
@@ -3953,7 +3953,7 @@
                   <a:srgbClr val="0F172A"/>
                 </a:solidFill>
               </a:rPr>
-              <a:t>Predictive Modeling</a:t>
+              <a:t>Power BI, Tableau &amp; LLMs</a:t>
             </a:r>
             <a:endParaRPr lang="en-US" sz="1300" dirty="0"/>
           </a:p>
@@ -3968,7 +3968,7 @@
                   <a:srgbClr val="0F172A"/>
                 </a:solidFill>
               </a:rPr>
-              <a:t>Workflow Automation</a:t>
+              <a:t>Predictive Modeling &amp; Automation</a:t>
             </a:r>
             <a:endParaRPr lang="en-US" sz="1300" dirty="0"/>
           </a:p>
@@ -5195,7 +5195,7 @@
                   <a:srgbClr val="0F172A"/>
                 </a:solidFill>
               </a:rPr>
-              <a:t>Led CRM configuration with secure auth, encryption, and role-based permissions.</a:t>
+              <a:t>Complete CRM build — coding, development, maintenance, secure auth, encryption, RBAC.</a:t>
             </a:r>
             <a:endParaRPr lang="en-US" sz="1100" dirty="0"/>
           </a:p>
@@ -5346,7 +5346,7 @@
                   <a:srgbClr val="0F172A"/>
                 </a:solidFill>
               </a:rPr>
-              <a:t>Built Power BI dashboards for incidents, access activity, and compliance metrics.</a:t>
+              <a:t>Power BI dashboards for incidents, compliance, and sales metrics — auditing, trends &amp; revenue forecasting.</a:t>
             </a:r>
             <a:endParaRPr lang="en-US" sz="1100" dirty="0"/>
           </a:p>
@@ -5461,7 +5461,7 @@
                   <a:srgbClr val="1E2761"/>
                 </a:solidFill>
               </a:rPr>
-              <a:t>Incident Response Program</a:t>
+              <a:t>Incident Response &amp; KnowBe4</a:t>
             </a:r>
             <a:endParaRPr lang="en-US" sz="1400" dirty="0"/>
           </a:p>
@@ -5497,7 +5497,7 @@
                   <a:srgbClr val="0F172A"/>
                 </a:solidFill>
               </a:rPr>
-              <a:t>Developed IR documentation, escalation playbooks, and remediation workflows.</a:t>
+              <a:t>IR playbooks, remediation workflows, and org-wide KnowBe4 security awareness training.</a:t>
             </a:r>
             <a:endParaRPr lang="en-US" sz="1100" dirty="0"/>
           </a:p>
@@ -5612,7 +5612,7 @@
                   <a:srgbClr val="1E2761"/>
                 </a:solidFill>
               </a:rPr>
-              <a:t>DR &amp; Business Continuity</a:t>
+              <a:t>IT Ticketing System</a:t>
             </a:r>
             <a:endParaRPr lang="en-US" sz="1400" dirty="0"/>
           </a:p>
@@ -5648,7 +5648,7 @@
                   <a:srgbClr val="0F172A"/>
                 </a:solidFill>
               </a:rPr>
-              <a:t>Backup, disaster recovery, and BCP procedures for hybrid infrastructure.</a:t>
+              <a:t>Built ticketing system for org-wide issue reporting, triage, and resolution tracking.</a:t>
             </a:r>
             <a:endParaRPr lang="en-US" sz="1100" dirty="0"/>
           </a:p>
@@ -5763,7 +5763,7 @@
                   <a:srgbClr val="1E2761"/>
                 </a:solidFill>
               </a:rPr>
-              <a:t>Internal AI Chatbots</a:t>
+              <a:t>Internal AI Chatbots (LLM)</a:t>
             </a:r>
             <a:endParaRPr lang="en-US" sz="1400" dirty="0"/>
           </a:p>
@@ -5799,7 +5799,7 @@
                   <a:srgbClr val="0F172A"/>
                 </a:solidFill>
               </a:rPr>
-              <a:t>Built AI chatbots for multiple departments with CRM, Microsoft 365, and SharePoint connectivity.</a:t>
+              <a:t>LLM-powered chatbots for multiple departments with CRM, Microsoft 365, and SharePoint connectivity.</a:t>
             </a:r>
             <a:endParaRPr lang="en-US" sz="1100" dirty="0"/>
           </a:p>
@@ -7068,7 +7068,7 @@
                   <a:srgbClr val="0F172A"/>
                 </a:solidFill>
               </a:rPr>
-              <a:t>Earn CISSP certification (in progress)</a:t>
+              <a:t>Earned CISSP certification</a:t>
             </a:r>
             <a:endParaRPr lang="en-US" sz="1500" dirty="0"/>
           </a:p>

</xml_diff>

<commit_message>
Update Professional Goals bullet capitalization
</commit_message>
<xml_diff>
--- a/Tracey-Scott-Portfolio.pptx
+++ b/Tracey-Scott-Portfolio.pptx
@@ -7068,7 +7068,7 @@
                   <a:srgbClr val="050816"/>
                 </a:solidFill>
               </a:rPr>
-              <a:t>Earned CISSP certification</a:t>
+              <a:t>Earned CISSP Certification</a:t>
             </a:r>
             <a:endParaRPr lang="en-US" sz="1500" dirty="0"/>
           </a:p>
@@ -7122,7 +7122,7 @@
                   <a:srgbClr val="050816"/>
                 </a:solidFill>
               </a:rPr>
-              <a:t>Mentor women entering cybersecurity via RTC &amp; ISSA</a:t>
+              <a:t>Mentor Women entering cybersecurity via RTC &amp; ISSA</a:t>
             </a:r>
             <a:endParaRPr lang="en-US" sz="1500" dirty="0"/>
           </a:p>

</xml_diff>

<commit_message>
Add Power Automate references across portfolio deck
Update Competencies, Key Projects, and Technical Proficiency slides
to highlight Power Automate usage for building internal AI Agents
serving HR, IT, and Sales departments.

Co-Authored-By: Claude Opus 4.6 <noreply@anthropic.com>
</commit_message>
<xml_diff>
--- a/Tracey-Scott-Portfolio.pptx
+++ b/Tracey-Scott-Portfolio.pptx
@@ -700,9 +700,9 @@
           </c:dLbls>
           <c:cat>
             <c:multiLvlStrRef>
-              <c:f>Sheet1!$A$2:$A$9</c:f>
+              <c:f>Sheet1!$A$2:$A$10</c:f>
               <c:multiLvlStrCache>
-                <c:ptCount val="8"/>
+                <c:ptCount val="9"/>
                 <c:lvl>
                   <c:pt idx="0">
                     <c:v>Cloud Security</c:v>
@@ -723,9 +723,12 @@
                     <c:v>Power BI</c:v>
                   </c:pt>
                   <c:pt idx="6">
+                    <c:v>Power Automate</c:v>
+                  </c:pt>
+                  <c:pt idx="7">
                     <c:v>Excel</c:v>
                   </c:pt>
-                  <c:pt idx="7">
+                  <c:pt idx="8">
                     <c:v>Virtualization</c:v>
                   </c:pt>
                 </c:lvl>
@@ -734,10 +737,10 @@
           </c:cat>
           <c:val>
             <c:numRef>
-              <c:f>Sheet1!$B$2:$B$9</c:f>
+              <c:f>Sheet1!$B$2:$B$10</c:f>
               <c:numCache>
                 <c:formatCode>General</c:formatCode>
-                <c:ptCount val="8"/>
+                <c:ptCount val="9"/>
                 <c:pt idx="0">
                   <c:v>92</c:v>
                 </c:pt>
@@ -757,9 +760,12 @@
                   <c:v>93</c:v>
                 </c:pt>
                 <c:pt idx="6">
+                  <c:v>90</c:v>
+                </c:pt>
+                <c:pt idx="7">
                   <c:v>95</c:v>
                 </c:pt>
-                <c:pt idx="7">
+                <c:pt idx="8">
                   <c:v>86</c:v>
                 </c:pt>
               </c:numCache>
@@ -3968,6 +3974,21 @@
                   <a:srgbClr val="050816"/>
                 </a:solidFill>
               </a:rPr>
+              <a:t>Power Automate &amp; AI Agents</a:t>
+            </a:r>
+            <a:endParaRPr lang="en-US" sz="1300" dirty="0"/>
+          </a:p>
+          <a:p>
+            <a:pPr marL="342900" indent="-342900">
+              <a:buSzPct val="100000"/>
+              <a:buChar char="•"/>
+            </a:pPr>
+            <a:r>
+              <a:rPr lang="en-US" sz="1300" dirty="0">
+                <a:solidFill>
+                  <a:srgbClr val="050816"/>
+                </a:solidFill>
+              </a:rPr>
               <a:t>Predictive Modeling &amp; Automation</a:t>
             </a:r>
             <a:endParaRPr lang="en-US" sz="1300" dirty="0"/>
@@ -5763,7 +5784,7 @@
                   <a:srgbClr val="0A0E27"/>
                 </a:solidFill>
               </a:rPr>
-              <a:t>Internal AI Chatbots (LLM)</a:t>
+              <a:t>Internal AI Agents (Power Automate)</a:t>
             </a:r>
             <a:endParaRPr lang="en-US" sz="1400" dirty="0"/>
           </a:p>
@@ -5799,7 +5820,7 @@
                   <a:srgbClr val="050816"/>
                 </a:solidFill>
               </a:rPr>
-              <a:t>LLM-powered chatbots for multiple departments with CRM, Microsoft 365, and SharePoint connectivity.</a:t>
+              <a:t>Power Automate AI Agents for HR, IT, and Sales with CRM, Microsoft 365, and SharePoint connectivity.</a:t>
             </a:r>
             <a:endParaRPr lang="en-US" sz="1100" dirty="0"/>
           </a:p>

</xml_diff>

<commit_message>
Remove CISSP Certification from What's Next slide
</commit_message>
<xml_diff>
--- a/Tracey-Scott-Portfolio.pptx
+++ b/Tracey-Scott-Portfolio.pptx
@@ -7077,24 +7077,6 @@
           <a:lstStyle/>
           <a:p>
             <a:pPr marL="342900" indent="-342900">
-              <a:spcAft>
-                <a:spcPts val="1400"/>
-              </a:spcAft>
-              <a:buSzPct val="100000"/>
-              <a:buChar char="•"/>
-            </a:pPr>
-            <a:r>
-              <a:rPr lang="en-US" sz="1500" dirty="0">
-                <a:solidFill>
-                  <a:srgbClr val="050816"/>
-                </a:solidFill>
-              </a:rPr>
-              <a:t>Earned CISSP Certification</a:t>
-            </a:r>
-            <a:endParaRPr lang="en-US" sz="1500" dirty="0"/>
-          </a:p>
-          <a:p>
-            <a:pPr marL="342900" indent="-342900">
               <a:buSzPct val="100000"/>
               <a:buChar char="•"/>
             </a:pPr>

</xml_diff>